<commit_message>
Groeninge-deck: twee zorgverleners, agenda volgt, en de 25 procent rechtgezet
AZ Groeninge heeft twee zorgverleners, niet drie. De kalenderdia noemt geen data
meer maar kondigt de agenda aan. En op de dia na optimalisatie stond de 25
procent nog tegen een baselinemeting in plaats van tegen de meting zonder zool
in dezelfde sessie - die dia zit ook in zes andere decks.
</commit_message>
<xml_diff>
--- a/PARADISE_presentatie/PARADISE_az_groeninge.pptx
+++ b/PARADISE_presentatie/PARADISE_az_groeninge.pptx
@@ -1971,7 +1971,7 @@
           </a:p>
           <a:p>
             <a:r>
-              <a:t>Tussen vandaag en uw eerste patiënt liggen vijf stappen. De opleidingsdag bij u duurt een halve dag: technologie in de voormiddag, gedragsbijsturing in de namiddag. In januari doen we een droogloop met een verzonnen deelnemer, op uw eigen toestellen. Die twee data zijn een voorstel — zeg nu of ze passen.</a:t>
+              <a:t>Tussen vandaag en uw eerste patiënt liggen vijf stappen. De opleidingsdag bij u duurt een halve dag: technologie in de voormiddag, gedragsbijsturing in de namiddag. In januari doen we een droogloop met een verzonnen deelnemer, op uw eigen toestellen. De agenda met de precieze data sturen we binnenkort rond.</a:t>
             </a:r>
           </a:p>
           <a:p/>
@@ -1982,7 +1982,7 @@
           </a:p>
           <a:p>
             <a:r>
-              <a:t>De data van december en januari zijn een voorstel. Ze liggen pas vast als de zes centra bevestigd hebben.</a:t>
+              <a:t>Zeg expliciet dat de agenda met de precieze data binnenkort volgt, en dat u die met de zes centra samen vastlegt.</a:t>
             </a:r>
           </a:p>
           <a:p/>
@@ -1993,7 +1993,7 @@
           </a:p>
           <a:p>
             <a:r>
-              <a:t>Vraag of 2 december en 15 januari passen, en wie er die dagen bij is.</a:t>
+              <a:t>Vraag welke dagen van de week bij hen het beste passen, en wie er dan bij moet zijn.</a:t>
             </a:r>
           </a:p>
         </p:txBody>
@@ -2068,7 +2068,7 @@
           </a:p>
           <a:p>
             <a:r>
-              <a:t>Vier dingen hebben we van u nodig, en geen daarvan is gegevensinvoer. Drie zorgverleners die de opleiding volgen, waarvan er twee gecertificeerd raken. Vierentwintig deelnemers over de inclusieperiode. En een looppad van tien meter, meer niet.</a:t>
+              <a:t>Vier dingen hebben we van u nodig, en geen daarvan is gegevensinvoer. Twee zorgverleners die de opleiding volgen en allebei gecertificeerd raken. Vierentwintig deelnemers over de inclusieperiode. En een looppad van tien meter, meer niet.</a:t>
             </a:r>
           </a:p>
           <a:p/>
@@ -45060,7 +45060,7 @@
                 </a:solidFill>
                 <a:latin typeface="Segoe UI"/>
               </a:rPr>
-              <a:t>De norm geldt per doelregio: piekdruk onder 200 kPa óf minstens 25% lager dan de baselinemeting van diezelfde regio.</a:t>
+              <a:t>De norm geldt per doelregio: piekdruk onder 200 kPa óf minstens 25% lager dan de meting zónder zool in dezelfde sessie.</a:t>
             </a:r>
           </a:p>
           <a:p>
@@ -60827,7 +60827,7 @@
                 </a:solidFill>
                 <a:latin typeface="Consolas"/>
               </a:rPr>
-              <a:t>VAN HIER TOT UW EERSTE PATIËNT · VOORSTEL</a:t>
+              <a:t>VAN HIER TOT UW EERSTE PATIËNT</a:t>
             </a:r>
           </a:p>
         </p:txBody>
@@ -60866,7 +60866,7 @@
                 </a:solidFill>
                 <a:latin typeface="Segoe UI"/>
               </a:rPr>
-              <a:t>Vijf stappen, vijf data</a:t>
+              <a:t>Vijf stappen, de agenda volgt binnenkort</a:t>
             </a:r>
           </a:p>
         </p:txBody>
@@ -61293,7 +61293,7 @@
                 </a:solidFill>
                 <a:latin typeface="Segoe UI"/>
               </a:rPr>
-              <a:t>wo 2 dec</a:t>
+              <a:t>december</a:t>
             </a:r>
           </a:p>
         </p:txBody>
@@ -61504,7 +61504,7 @@
                 </a:solidFill>
                 <a:latin typeface="Segoe UI"/>
               </a:rPr>
-              <a:t>vr 15 jan</a:t>
+              <a:t>januari</a:t>
             </a:r>
           </a:p>
         </p:txBody>
@@ -61926,7 +61926,7 @@
                 </a:solidFill>
                 <a:latin typeface="Segoe UI"/>
               </a:rPr>
-              <a:t>di 23 feb</a:t>
+              <a:t>februari</a:t>
             </a:r>
           </a:p>
         </p:txBody>
@@ -62271,7 +62271,7 @@
                 </a:solidFill>
                 <a:latin typeface="Segoe UI"/>
               </a:rPr>
-              <a:t>Drie zorgverleners</a:t>
+              <a:t>Twee zorgverleners</a:t>
             </a:r>
           </a:p>
         </p:txBody>
@@ -62310,7 +62310,7 @@
                 </a:solidFill>
                 <a:latin typeface="Segoe UI"/>
               </a:rPr>
-              <a:t>Podoloog, pedorthist en een arts. Twee moeten gecertificeerd zijn; de derde loopt mee, zodat één uitval het criterium niet doet kantelen.</a:t>
+              <a:t>Podoloog en pedorthist, met een arts die de geschiktheid bevestigt. Allebei gecertificeerd. Met precies twee is er geen marge, dus een back-up met naam is geen luxe.</a:t>
             </a:r>
           </a:p>
         </p:txBody>
@@ -62349,7 +62349,7 @@
                 </a:solidFill>
                 <a:latin typeface="Consolas"/>
               </a:rPr>
-              <a:t>3</a:t>
+              <a:t>2</a:t>
             </a:r>
           </a:p>
         </p:txBody>

</xml_diff>